<commit_message>
Thêm Bài tập cuối chương I (Toán 11); sửa hiển thị dấu trừ trong slide; phân bố đáp án Bài 5, 6 Toán 10
</commit_message>
<xml_diff>
--- a/slides/Toan10/Slide_TOAN10_Bai5_T16-17.pptx
+++ b/slides/Toan10/Slide_TOAN10_Bai5_T16-17.pptx
@@ -5507,7 +5507,7 @@
                 </a:r>
                 <a:r>
                   <a:rPr lang="vi-VN"/>
-                  <a:t>P=\frac{2\tan\ \alpha-3}{3\tan\ \alpha+2}=\frac{3}{11}</a:t>
+                  <a:t>P=\frac{2\tan\ \alpha−3}{3\tan\ \alpha+2}=\frac{3}{11}</a:t>
                 </a:r>
               </a:p>
             </p:txBody>
@@ -10921,7 +10921,7 @@
                 </a:pPr>
                 <a:r>
                   <a:rPr lang="vi-VN"/>
-                  <a:t>\tan\ 120^\circ=-\sqrt{3}</a:t>
+                  <a:t>\tan\ 120^\circ=−\sqrt{3}</a:t>
                 </a:r>
                 <a:r>
                   <a:rPr sz="2400">

</xml_diff>